<commit_message>
Update OpenRouter setup, UI and final submission presentation
</commit_message>
<xml_diff>
--- a/AI_Operations_Assistant.pptx
+++ b/AI_Operations_Assistant.pptx
@@ -2,36 +2,36 @@
 <file path=ppt/presentation.xml><?xml version="1.0" encoding="utf-8"?>
 <p:presentation xmlns:p="http://schemas.openxmlformats.org/presentationml/2006/main" embedTrueTypeFonts="1" saveSubsetFonts="0">
   <p:sldMasterIdLst>
-    <p:sldMasterId xmlns:r="http://schemas.openxmlformats.org/officeDocument/2006/relationships" id="2147483648" r:id="R547f1d3f311242d9"/>
+    <p:sldMasterId xmlns:r="http://schemas.openxmlformats.org/officeDocument/2006/relationships" id="2147483648" r:id="R639b0b8fb76f4b1d"/>
   </p:sldMasterIdLst>
   <p:notesMasterIdLst>
-    <p:notesMasterId xmlns:r="http://schemas.openxmlformats.org/officeDocument/2006/relationships" r:id="Rcd9fd7e44d4345b9"/>
+    <p:notesMasterId xmlns:r="http://schemas.openxmlformats.org/officeDocument/2006/relationships" r:id="Rd65b8a98f4ff4617"/>
   </p:notesMasterIdLst>
   <p:sldIdLst>
-    <p:sldId xmlns:r="http://schemas.openxmlformats.org/officeDocument/2006/relationships" id="256" r:id="Ra1099725cc394175"/>
-    <p:sldId xmlns:r="http://schemas.openxmlformats.org/officeDocument/2006/relationships" id="257" r:id="R9e5d41e1a529496b"/>
-    <p:sldId xmlns:r="http://schemas.openxmlformats.org/officeDocument/2006/relationships" id="258" r:id="Rc706d727988b4a67"/>
-    <p:sldId xmlns:r="http://schemas.openxmlformats.org/officeDocument/2006/relationships" id="259" r:id="Rbd47717da4574d97"/>
-    <p:sldId xmlns:r="http://schemas.openxmlformats.org/officeDocument/2006/relationships" id="260" r:id="Ra10006e341454868"/>
-    <p:sldId xmlns:r="http://schemas.openxmlformats.org/officeDocument/2006/relationships" id="261" r:id="R3ec2f5106d6d410a"/>
-    <p:sldId xmlns:r="http://schemas.openxmlformats.org/officeDocument/2006/relationships" id="262" r:id="Rfb6b94904eb342c6"/>
-    <p:sldId xmlns:r="http://schemas.openxmlformats.org/officeDocument/2006/relationships" id="263" r:id="Rd9a78b979eab4991"/>
-    <p:sldId xmlns:r="http://schemas.openxmlformats.org/officeDocument/2006/relationships" id="264" r:id="R8ae90b96c30a4a88"/>
-    <p:sldId xmlns:r="http://schemas.openxmlformats.org/officeDocument/2006/relationships" id="265" r:id="Rf9de7334e31c4ac3"/>
-    <p:sldId xmlns:r="http://schemas.openxmlformats.org/officeDocument/2006/relationships" id="266" r:id="R2ce5e18c1f904258"/>
-    <p:sldId xmlns:r="http://schemas.openxmlformats.org/officeDocument/2006/relationships" id="267" r:id="Rf908f1067eb74dc8"/>
-    <p:sldId xmlns:r="http://schemas.openxmlformats.org/officeDocument/2006/relationships" id="268" r:id="R17ae8279df16434b"/>
-    <p:sldId xmlns:r="http://schemas.openxmlformats.org/officeDocument/2006/relationships" id="269" r:id="R49d1dddd20904c7e"/>
+    <p:sldId xmlns:r="http://schemas.openxmlformats.org/officeDocument/2006/relationships" id="256" r:id="R95ee243bf2594ba6"/>
+    <p:sldId xmlns:r="http://schemas.openxmlformats.org/officeDocument/2006/relationships" id="257" r:id="R3801ec7ec6d4482b"/>
+    <p:sldId xmlns:r="http://schemas.openxmlformats.org/officeDocument/2006/relationships" id="258" r:id="R50b0e137c2eb4801"/>
+    <p:sldId xmlns:r="http://schemas.openxmlformats.org/officeDocument/2006/relationships" id="259" r:id="R164639d2235844f2"/>
+    <p:sldId xmlns:r="http://schemas.openxmlformats.org/officeDocument/2006/relationships" id="260" r:id="R41c5b87a2b6c4eb4"/>
+    <p:sldId xmlns:r="http://schemas.openxmlformats.org/officeDocument/2006/relationships" id="261" r:id="R76b8a676ba184469"/>
+    <p:sldId xmlns:r="http://schemas.openxmlformats.org/officeDocument/2006/relationships" id="262" r:id="R79fb04bd57364c10"/>
+    <p:sldId xmlns:r="http://schemas.openxmlformats.org/officeDocument/2006/relationships" id="263" r:id="R240b444cf45e49b8"/>
+    <p:sldId xmlns:r="http://schemas.openxmlformats.org/officeDocument/2006/relationships" id="264" r:id="R9200c861f8684799"/>
+    <p:sldId xmlns:r="http://schemas.openxmlformats.org/officeDocument/2006/relationships" id="265" r:id="R5534d4da863e4b57"/>
+    <p:sldId xmlns:r="http://schemas.openxmlformats.org/officeDocument/2006/relationships" id="266" r:id="R7ab25325e38e438f"/>
+    <p:sldId xmlns:r="http://schemas.openxmlformats.org/officeDocument/2006/relationships" id="267" r:id="Rd8987099db6c4020"/>
+    <p:sldId xmlns:r="http://schemas.openxmlformats.org/officeDocument/2006/relationships" id="268" r:id="Rb56d9dcf077c4032"/>
+    <p:sldId xmlns:r="http://schemas.openxmlformats.org/officeDocument/2006/relationships" id="269" r:id="Rfeaa6ca1b3744538"/>
   </p:sldIdLst>
   <p:sldSz cx="12192000" cy="6858000"/>
   <p:notesSz cx="6858000" cy="9144000"/>
   <p:embeddedFontLst>
     <p:embeddedFont>
       <p:font typeface="OpenAI Sans"/>
-      <p:regular xmlns:r="http://schemas.openxmlformats.org/officeDocument/2006/relationships" r:id="Rffd044f9bdff45f3"/>
-      <p:bold xmlns:r="http://schemas.openxmlformats.org/officeDocument/2006/relationships" r:id="R458f34a825d14aff"/>
-      <p:italic xmlns:r="http://schemas.openxmlformats.org/officeDocument/2006/relationships" r:id="Rbbb9a34e6e6b4be1"/>
-      <p:boldItalic xmlns:r="http://schemas.openxmlformats.org/officeDocument/2006/relationships" r:id="R1f2126818d33452f"/>
+      <p:regular xmlns:r="http://schemas.openxmlformats.org/officeDocument/2006/relationships" r:id="R3f42cb4db5174476"/>
+      <p:bold xmlns:r="http://schemas.openxmlformats.org/officeDocument/2006/relationships" r:id="Rc8856427b20b4e50"/>
+      <p:italic xmlns:r="http://schemas.openxmlformats.org/officeDocument/2006/relationships" r:id="R060fdfabe6cb47d4"/>
+      <p:boldItalic xmlns:r="http://schemas.openxmlformats.org/officeDocument/2006/relationships" r:id="Rbb23b310a23b4cc4"/>
     </p:embeddedFont>
   </p:embeddedFontLst>
 </p:presentation>
@@ -570,7 +570,7 @@
               <a:buNone/>
             </a:pPr>
             <a:r>
-              <a:t>Evidence: docs/VALIDATION.md, tests/, docs/demo-transcript.txt. Initial run: 21 passed in 12.60 seconds on Windows with Python 3.12. The SDK contract test is mocked. No model accuracy or production performance claim is made.</a:t>
+              <a:t>Evidence: docs/VALIDATION.md, tests/, docs/demo-transcript.txt. Run: 36 passed in 44.59 seconds on 13 September 2026, Windows with Python 3.12. Five live acceptance checks passed using openrouter/free, recorded in docs/live-check.json. The small sample does not establish broad model accuracy or production performance.</a:t>
             </a:r>
             <a:endParaRPr/>
           </a:p>
@@ -791,7 +791,7 @@
           <a:lstStyle xmlns:a="http://schemas.openxmlformats.org/drawingml/2006/main"/>
           <a:p xmlns:a="http://schemas.openxmlformats.org/drawingml/2006/main">
             <a:r>
-              <a:t>The source package includes README, sample data, configuration, architecture and tests. GitHub publication needs authenticated account access. The live evaluation or recording and a live LLM acceptance run remain submission steps.</a:t>
+              <a:t>The source package includes README, sample data, configuration, architecture and tests. Repository: https://github.com/rasingod/ai-operations-assistant . Five live OpenRouter acceptance checks passed. Deliver the live assessment using the supplied guide. Keep API credentials local.</a:t>
             </a:r>
             <a:endParaRPr/>
           </a:p>
@@ -1111,7 +1111,7 @@
               <a:buNone/>
             </a:pPr>
             <a:r>
-              <a:t>Source: ops_assistant/router.py. API reference: https://developers.openai.com/api/docs/guides/function-calling . The SDK uses Chat Completions with exactly one function call requested. Tool choice is required, with answer and clarify schemas for no-tool behavior. Actual tool results are formatted locally.</a:t>
+              <a:t>Source: ops_assistant/router.py. API reference: https://openrouter.ai/docs/guides/features/tool-calling . The SDK uses the OpenRouter base URL and requests a required function call. The app validates exactly one call and permits one correction for malformed output. Tool choice is required, with answer and clarify schemas for no-tool behavior. Actual tool results are formatted locally.</a:t>
             </a:r>
             <a:endParaRPr/>
           </a:p>
@@ -3305,14 +3305,14 @@
   </p:cSld>
   <p:clrMap bg1="dk1" tx1="lt1" bg2="dk2" tx2="lt2" accent1="accent1" accent2="accent2" accent3="accent3" accent4="accent4" accent5="accent5" accent6="accent6" hlink="hlink" folHlink="folHlink"/>
   <p:sldLayoutIdLst>
-    <p:sldLayoutId xmlns:r="http://schemas.openxmlformats.org/officeDocument/2006/relationships" id="2147483649" r:id="R9832c282319944ed"/>
-    <p:sldLayoutId xmlns:r="http://schemas.openxmlformats.org/officeDocument/2006/relationships" id="2147483650" r:id="Rb0cca2f30e344451"/>
-    <p:sldLayoutId xmlns:r="http://schemas.openxmlformats.org/officeDocument/2006/relationships" id="2147483651" r:id="R71ed83c85d72427a"/>
-    <p:sldLayoutId xmlns:r="http://schemas.openxmlformats.org/officeDocument/2006/relationships" id="2147483652" r:id="R334c03fda4814690"/>
-    <p:sldLayoutId xmlns:r="http://schemas.openxmlformats.org/officeDocument/2006/relationships" id="2147483653" r:id="Rbf385b232a374453"/>
-    <p:sldLayoutId xmlns:r="http://schemas.openxmlformats.org/officeDocument/2006/relationships" id="2147483654" r:id="R81c67cbaa1e14903"/>
-    <p:sldLayoutId xmlns:r="http://schemas.openxmlformats.org/officeDocument/2006/relationships" id="2147483655" r:id="Re6c6ae852d634212"/>
-    <p:sldLayoutId xmlns:r="http://schemas.openxmlformats.org/officeDocument/2006/relationships" id="2147483656" r:id="Rfda03fe7050c4a98"/>
+    <p:sldLayoutId xmlns:r="http://schemas.openxmlformats.org/officeDocument/2006/relationships" id="2147483649" r:id="Re26cdb4b92eb4a26"/>
+    <p:sldLayoutId xmlns:r="http://schemas.openxmlformats.org/officeDocument/2006/relationships" id="2147483650" r:id="R86377923f1954ba9"/>
+    <p:sldLayoutId xmlns:r="http://schemas.openxmlformats.org/officeDocument/2006/relationships" id="2147483651" r:id="R3041c516afc541a1"/>
+    <p:sldLayoutId xmlns:r="http://schemas.openxmlformats.org/officeDocument/2006/relationships" id="2147483652" r:id="Ra8699fa99a7340fc"/>
+    <p:sldLayoutId xmlns:r="http://schemas.openxmlformats.org/officeDocument/2006/relationships" id="2147483653" r:id="R44fb4c4806ea4a9b"/>
+    <p:sldLayoutId xmlns:r="http://schemas.openxmlformats.org/officeDocument/2006/relationships" id="2147483654" r:id="Re4091c063d1f4e2a"/>
+    <p:sldLayoutId xmlns:r="http://schemas.openxmlformats.org/officeDocument/2006/relationships" id="2147483655" r:id="R8fae418e545e43c1"/>
+    <p:sldLayoutId xmlns:r="http://schemas.openxmlformats.org/officeDocument/2006/relationships" id="2147483656" r:id="R14257528c3074ad9"/>
   </p:sldLayoutIdLst>
   <p:hf hdr="0" dt="0"/>
   <p:txStyles>
@@ -4294,7 +4294,7 @@
           <p:nvPr/>
         </p:nvPicPr>
         <p:blipFill>
-          <a:blip xmlns:r="http://schemas.openxmlformats.org/officeDocument/2006/relationships" xmlns:a="http://schemas.openxmlformats.org/drawingml/2006/main" r:embed="R79a0799e32e540f5"/>
+          <a:blip xmlns:r="http://schemas.openxmlformats.org/officeDocument/2006/relationships" xmlns:a="http://schemas.openxmlformats.org/drawingml/2006/main" r:embed="R852b42e27f6644c8"/>
           <a:srcRect xmlns:a="http://schemas.openxmlformats.org/drawingml/2006/main" l="8269" t="0" r="8269" b="0"/>
           <a:stretch xmlns:a="http://schemas.openxmlformats.org/drawingml/2006/main"/>
         </p:blipFill>
@@ -5405,7 +5405,7 @@
                 <a:ea typeface="OpenAI Sans"/>
                 <a:cs typeface="OpenAI Sans"/>
               </a:rPr>
-              <a:t>21 tests passed</a:t>
+              <a:t>36 tests passed</a:t>
             </a:r>
           </a:p>
           <a:p xmlns:a="http://schemas.openxmlformats.org/drawingml/2006/main">
@@ -5723,7 +5723,7 @@
                 <a:ea typeface="OpenAI Sans"/>
                 <a:cs typeface="OpenAI Sans"/>
               </a:rPr>
-              <a:t>Evidence boundary</a:t>
+              <a:t>Live OpenRouter checks</a:t>
             </a:r>
           </a:p>
           <a:p xmlns:a="http://schemas.openxmlformats.org/drawingml/2006/main">
@@ -5756,7 +5756,7 @@
                 <a:ea typeface="OpenAI Sans"/>
                 <a:cs typeface="OpenAI Sans"/>
               </a:rPr>
-              <a:t>The offline demo completed successfully.</a:t>
+              <a:t>All five workflow checks passed with openrouter/free.</a:t>
             </a:r>
           </a:p>
           <a:p xmlns:a="http://schemas.openxmlformats.org/drawingml/2006/main">
@@ -5811,7 +5811,7 @@
                 <a:ea typeface="OpenAI Sans"/>
                 <a:cs typeface="OpenAI Sans"/>
               </a:rPr>
-              <a:t>Live model behavior still requires an API key and an acceptance run.</a:t>
+              <a:t>Knowledge, lookup, missing details, draft and confirmed creation.</a:t>
             </a:r>
           </a:p>
         </p:txBody>
@@ -8473,7 +8473,30 @@
                 <a:ea typeface="OpenAI Sans"/>
                 <a:cs typeface="OpenAI Sans"/>
               </a:rPr>
-              <a:t>Source, report and demonstration guide</a:t>
+              <a:t>GitHub source and project report</a:t>
+            </a:r>
+          </a:p>
+          <a:p xmlns:a="http://schemas.openxmlformats.org/drawingml/2006/main">
+            <a:pPr>
+              <a:defRPr sz="1725">
+                <a:solidFill>
+                  <a:srgbClr val="FFFFFF"/>
+                </a:solidFill>
+                <a:latin typeface="OpenAI Sans"/>
+                <a:ea typeface="OpenAI Sans"/>
+                <a:cs typeface="OpenAI Sans"/>
+              </a:defRPr>
+            </a:pPr>
+            <a:r>
+              <a:rPr sz="1725">
+                <a:solidFill>
+                  <a:srgbClr val="FFFFFF"/>
+                </a:solidFill>
+                <a:latin typeface="OpenAI Sans"/>
+                <a:ea typeface="OpenAI Sans"/>
+                <a:cs typeface="OpenAI Sans"/>
+              </a:rPr>
+              <a:t>Live demonstration guide</a:t>
             </a:r>
           </a:p>
           <a:p xmlns:a="http://schemas.openxmlformats.org/drawingml/2006/main">
@@ -10950,7 +10973,7 @@
           <a:lstStyle xmlns:a="http://schemas.openxmlformats.org/drawingml/2006/main"/>
           <a:p xmlns:a="http://schemas.openxmlformats.org/drawingml/2006/main">
             <a:r>
-              <a:t>LLM function calling</a:t>
+              <a:t>OpenRouter function calling</a:t>
             </a:r>
           </a:p>
         </p:txBody>
@@ -11177,7 +11200,7 @@
                 <a:ea typeface="OpenAI Sans"/>
                 <a:cs typeface="OpenAI Sans"/>
               </a:rPr>
-              <a:t>Model decision</a:t>
+              <a:t>OpenRouter planner</a:t>
             </a:r>
           </a:p>
           <a:p xmlns:a="http://schemas.openxmlformats.org/drawingml/2006/main">
@@ -11211,7 +11234,7 @@
                 <a:ea typeface="OpenAI Sans"/>
                 <a:cs typeface="OpenAI Sans"/>
               </a:rPr>
-              <a:t>A system prompt describes allowed actions.</a:t>
+              <a:t>An OpenAI-compatible SDK connects to OpenRouter.</a:t>
             </a:r>
           </a:p>
           <a:p xmlns:a="http://schemas.openxmlformats.org/drawingml/2006/main">

</xml_diff>